<commit_message>
Lock Figures 1–3 structure, panels, and captions
</commit_message>
<xml_diff>
--- a/figures/fig1_pipeline/Fig1_panels.pptx
+++ b/figures/fig1_pipeline/Fig1_panels.pptx
@@ -24584,7 +24584,7 @@
         </p:nvSpPr>
         <p:spPr bwMode="auto">
           <a:xfrm>
-            <a:off x="0" y="0"/>
+            <a:off x="0" y="38100"/>
             <a:ext cx="12192000" cy="457200"/>
           </a:xfrm>
           <a:prstGeom prst="rect">
@@ -24777,7 +24777,7 @@
               <a:tabLst/>
             </a:pPr>
             <a:r>
-              <a:rPr kumimoji="0" lang="en-US" altLang="en-US" sz="1800" b="1" i="0" u="none" strike="noStrike" cap="none" normalizeH="0" baseline="0">
+              <a:rPr kumimoji="0" lang="en-US" altLang="en-US" sz="1800" b="1" i="0" u="none" strike="noStrike" cap="none" normalizeH="0" baseline="0" dirty="0">
                 <a:ln>
                   <a:noFill/>
                 </a:ln>
@@ -24790,7 +24790,7 @@
               <a:t>Panel D</a:t>
             </a:r>
             <a:r>
-              <a:rPr kumimoji="0" lang="en-US" altLang="en-US" sz="1800" b="0" i="0" u="none" strike="noStrike" cap="none" normalizeH="0" baseline="0">
+              <a:rPr kumimoji="0" lang="en-US" altLang="en-US" sz="1800" b="0" i="0" u="none" strike="noStrike" cap="none" normalizeH="0" baseline="0" dirty="0">
                 <a:ln>
                   <a:noFill/>
                 </a:ln>
@@ -24802,7 +24802,7 @@
               </a:rPr>
               <a:t> – Pathways &amp; Module Scores</a:t>
             </a:r>
-            <a:endParaRPr kumimoji="0" lang="en-US" altLang="en-US" sz="1800" b="0" i="0" u="none" strike="noStrike" cap="none" normalizeH="0" baseline="0">
+            <a:endParaRPr kumimoji="0" lang="en-US" altLang="en-US" sz="1800" b="0" i="0" u="none" strike="noStrike" cap="none" normalizeH="0" baseline="0" dirty="0">
               <a:ln>
                 <a:noFill/>
               </a:ln>
@@ -24817,10 +24817,10 @@
       </p:sp>
       <p:pic>
         <p:nvPicPr>
-          <p:cNvPr id="2" name="Picture 1">
+          <p:cNvPr id="6" name="Picture 5" descr="A graph of a graph with blue and orange lines&#10;&#10;AI-generated content may be incorrect.">
             <a:extLst>
               <a:ext uri="{FF2B5EF4-FFF2-40B4-BE49-F238E27FC236}">
-                <a16:creationId xmlns:a16="http://schemas.microsoft.com/office/drawing/2014/main" id="{5CA745D2-FA24-2057-66F6-7ED132A40D15}"/>
+                <a16:creationId xmlns:a16="http://schemas.microsoft.com/office/drawing/2014/main" id="{3CE9A5FF-43A7-2155-5353-FB4C4B9CB894}"/>
               </a:ext>
             </a:extLst>
           </p:cNvPr>
@@ -24837,38 +24837,8 @@
         </p:blipFill>
         <p:spPr>
           <a:xfrm>
-            <a:off x="5939790" y="1358900"/>
-            <a:ext cx="4724400" cy="4140200"/>
-          </a:xfrm>
-          <a:prstGeom prst="rect">
-            <a:avLst/>
-          </a:prstGeom>
-        </p:spPr>
-      </p:pic>
-      <p:pic>
-        <p:nvPicPr>
-          <p:cNvPr id="4" name="Picture 3">
-            <a:extLst>
-              <a:ext uri="{FF2B5EF4-FFF2-40B4-BE49-F238E27FC236}">
-                <a16:creationId xmlns:a16="http://schemas.microsoft.com/office/drawing/2014/main" id="{14080850-7E9E-1BFA-AB62-322387AA1818}"/>
-              </a:ext>
-            </a:extLst>
-          </p:cNvPr>
-          <p:cNvPicPr>
-            <a:picLocks noChangeAspect="1"/>
-          </p:cNvPicPr>
-          <p:nvPr/>
-        </p:nvPicPr>
-        <p:blipFill>
-          <a:blip r:embed="rId4"/>
-          <a:stretch>
-            <a:fillRect/>
-          </a:stretch>
-        </p:blipFill>
-        <p:spPr>
-          <a:xfrm>
-            <a:off x="0" y="1250950"/>
-            <a:ext cx="5003800" cy="4356100"/>
+            <a:off x="2883048" y="623324"/>
+            <a:ext cx="6819751" cy="5955276"/>
           </a:xfrm>
           <a:prstGeom prst="rect">
             <a:avLst/>

</xml_diff>

<commit_message>
Lock Figure 1: pipeline schematic and finalized caption
</commit_message>
<xml_diff>
--- a/figures/fig1_pipeline/Fig1_panels.pptx
+++ b/figures/fig1_pipeline/Fig1_panels.pptx
@@ -4094,6 +4094,15 @@
             <a:cs typeface="Arial" panose="020B0604020202020204" pitchFamily="34" charset="0"/>
           </a:endParaRPr>
         </a:p>
+        <a:p>
+          <a:pPr>
+            <a:buNone/>
+          </a:pPr>
+          <a:endParaRPr lang="en-US" sz="1300" dirty="0">
+            <a:latin typeface="Helvetica" pitchFamily="2" charset="0"/>
+            <a:cs typeface="Arial" panose="020B0604020202020204" pitchFamily="34" charset="0"/>
+          </a:endParaRPr>
+        </a:p>
       </dgm:t>
     </dgm:pt>
     <dgm:pt modelId="{61F85F90-4AF3-4346-AB83-43F4E1E7EA04}" type="sibTrans" cxnId="{0A36E6D6-90F2-474D-9EC0-DAB8775DDB97}">
@@ -4876,7 +4885,7 @@
           </a:endParaRPr>
         </a:p>
         <a:p>
-          <a:pPr algn="l"/>
+          <a:pPr algn="ctr"/>
           <a:r>
             <a:rPr lang="en-US" sz="1400" dirty="0">
               <a:latin typeface="Helvetica" pitchFamily="2" charset="0"/>
@@ -4886,7 +4895,7 @@
           </a:r>
         </a:p>
         <a:p>
-          <a:pPr algn="l"/>
+          <a:pPr algn="ctr"/>
           <a:r>
             <a:rPr lang="en-US" sz="1400" dirty="0">
               <a:latin typeface="Helvetica" pitchFamily="2" charset="0"/>
@@ -4905,21 +4914,21 @@
           </a:r>
         </a:p>
         <a:p>
-          <a:pPr algn="l"/>
+          <a:pPr algn="ctr"/>
           <a:endParaRPr lang="en-US" sz="700" dirty="0">
             <a:latin typeface="Helvetica" pitchFamily="2" charset="0"/>
             <a:cs typeface="Arial" panose="020B0604020202020204" pitchFamily="34" charset="0"/>
           </a:endParaRPr>
         </a:p>
         <a:p>
-          <a:pPr algn="l"/>
+          <a:pPr algn="ctr"/>
           <a:endParaRPr lang="en-US" sz="700" dirty="0">
             <a:latin typeface="Helvetica" pitchFamily="2" charset="0"/>
             <a:cs typeface="Courier New" panose="02070309020205020404" pitchFamily="49" charset="0"/>
           </a:endParaRPr>
         </a:p>
         <a:p>
-          <a:pPr algn="l"/>
+          <a:pPr algn="ctr"/>
           <a:r>
             <a:rPr lang="en-US" sz="1100" dirty="0">
               <a:latin typeface="Helvetica" pitchFamily="2" charset="0"/>
@@ -8345,6 +8354,70 @@
         </a:p>
       </dgm:t>
     </dgm:pt>
+    <dgm:pt modelId="{B0368CA6-3685-7049-9DC6-C905636ABE29}">
+      <dgm:prSet custT="1"/>
+      <dgm:spPr/>
+      <dgm:t>
+        <a:bodyPr/>
+        <a:lstStyle/>
+        <a:p>
+          <a:pPr>
+            <a:buFont typeface="Courier New" panose="02070309020205020404" pitchFamily="49" charset="0"/>
+            <a:buChar char="o"/>
+          </a:pPr>
+          <a:endParaRPr lang="en-US" sz="900" b="0" i="0" u="none" dirty="0">
+            <a:latin typeface="Helvetica" pitchFamily="2" charset="0"/>
+          </a:endParaRPr>
+        </a:p>
+      </dgm:t>
+    </dgm:pt>
+    <dgm:pt modelId="{832D3D1D-F3EC-354B-83D2-C9577F7CD6F5}" type="parTrans" cxnId="{6302DF1B-1E63-954C-BE02-31CB1CAC04DB}">
+      <dgm:prSet/>
+      <dgm:spPr/>
+      <dgm:t>
+        <a:bodyPr/>
+        <a:lstStyle/>
+        <a:p>
+          <a:endParaRPr lang="en-US"/>
+        </a:p>
+      </dgm:t>
+    </dgm:pt>
+    <dgm:pt modelId="{5C7AEDA3-B26D-9A4A-9C25-646FDD6B5C48}" type="sibTrans" cxnId="{6302DF1B-1E63-954C-BE02-31CB1CAC04DB}">
+      <dgm:prSet/>
+      <dgm:spPr/>
+      <dgm:t>
+        <a:bodyPr/>
+        <a:lstStyle/>
+        <a:p>
+          <a:endParaRPr lang="en-US"/>
+        </a:p>
+      </dgm:t>
+    </dgm:pt>
+    <dgm:pt modelId="{42B02ACF-D616-EC44-9BE1-D85A6BD01522}">
+      <dgm:prSet custT="1"/>
+      <dgm:spPr/>
+      <dgm:t>
+        <a:bodyPr/>
+        <a:lstStyle/>
+        <a:p>
+          <a:pPr>
+            <a:buFont typeface="Arial" panose="020B0604020202020204" pitchFamily="34" charset="0"/>
+            <a:buChar char="•"/>
+          </a:pPr>
+          <a:endParaRPr lang="en-US" sz="900" b="0" i="0" u="none" dirty="0">
+            <a:latin typeface="Helvetica" pitchFamily="2" charset="0"/>
+          </a:endParaRPr>
+        </a:p>
+      </dgm:t>
+    </dgm:pt>
+    <dgm:pt modelId="{61A02348-1472-D146-A7DD-46D29810294F}" type="parTrans" cxnId="{95D195C0-F1D1-4742-8F3C-71A40ACD34BA}">
+      <dgm:prSet/>
+      <dgm:spPr/>
+    </dgm:pt>
+    <dgm:pt modelId="{CFFDA296-0EAD-AA48-96D9-F25D49F9ECE9}" type="sibTrans" cxnId="{95D195C0-F1D1-4742-8F3C-71A40ACD34BA}">
+      <dgm:prSet/>
+      <dgm:spPr/>
+    </dgm:pt>
     <dgm:pt modelId="{2297FE90-F822-FD41-9896-D1D149AA928E}" type="pres">
       <dgm:prSet presAssocID="{62282A74-D35E-914B-81CD-953B68F50298}" presName="Name0" presStyleCnt="0">
         <dgm:presLayoutVars>
@@ -8538,7 +8611,7 @@
     <dgm:cxn modelId="{A3DF9700-9DAC-E04E-9B91-F44315A717E3}" srcId="{528B0447-750C-B84B-B38E-6C4CE45E8FD1}" destId="{134844F8-E973-3E46-BD4B-F27661DC996E}" srcOrd="0" destOrd="0" parTransId="{F8E97794-8D11-BF4F-8392-F86D3F3B207C}" sibTransId="{62C37F00-FF78-C949-BCC6-17F780611390}"/>
     <dgm:cxn modelId="{99B32A02-C1D7-D54B-9393-F3D4C26A5632}" type="presOf" srcId="{F2A05C70-64D0-174F-96CA-8D8886A42700}" destId="{BB209C84-3A08-FB4C-A922-B95B7FDD58EF}" srcOrd="0" destOrd="0" presId="urn:microsoft.com/office/officeart/2005/8/layout/hList1"/>
     <dgm:cxn modelId="{02F30D05-80E5-FC4B-896B-E1656332323A}" type="presOf" srcId="{C7D5B991-1BC7-8C4E-82D8-FFDF94B0E59C}" destId="{1A71BF6A-449B-F446-83EE-5DE84234424B}" srcOrd="0" destOrd="3" presId="urn:microsoft.com/office/officeart/2005/8/layout/hList1"/>
-    <dgm:cxn modelId="{7477720D-CAEC-DC47-833B-D9886F9FC833}" type="presOf" srcId="{896F5E05-25CF-D043-86FA-E1CEA8AB293A}" destId="{1A71BF6A-449B-F446-83EE-5DE84234424B}" srcOrd="0" destOrd="10" presId="urn:microsoft.com/office/officeart/2005/8/layout/hList1"/>
+    <dgm:cxn modelId="{7477720D-CAEC-DC47-833B-D9886F9FC833}" type="presOf" srcId="{896F5E05-25CF-D043-86FA-E1CEA8AB293A}" destId="{1A71BF6A-449B-F446-83EE-5DE84234424B}" srcOrd="0" destOrd="11" presId="urn:microsoft.com/office/officeart/2005/8/layout/hList1"/>
     <dgm:cxn modelId="{AD8D1D0E-A815-2646-B88E-07FDA379E639}" srcId="{3C31C087-F44D-3242-BEF1-1419442F0CB5}" destId="{AB21FAB3-D1DD-054E-BE72-C786F59958BA}" srcOrd="6" destOrd="0" parTransId="{407B32B4-92CC-C044-850A-9327AA1E9A86}" sibTransId="{F77A925D-7954-CA46-B3BF-636E9D0B7C0D}"/>
     <dgm:cxn modelId="{84216B11-1E62-BF42-83E2-7A83275D2E11}" type="presOf" srcId="{4302F14E-AA13-BD45-8AB9-BFB53D1E1BAB}" destId="{2393E5E2-B7D6-5649-940D-13F8B1FB5DDE}" srcOrd="0" destOrd="4" presId="urn:microsoft.com/office/officeart/2005/8/layout/hList1"/>
     <dgm:cxn modelId="{5EBC8911-AE73-574B-9F67-2C38EAC67B8C}" srcId="{528B0447-750C-B84B-B38E-6C4CE45E8FD1}" destId="{C4D63277-072D-2449-A305-78FF1D0E393F}" srcOrd="6" destOrd="0" parTransId="{639AF8AF-5E08-B04A-AACD-5A0B25B6321B}" sibTransId="{B5EC2AEB-0AB4-2549-9671-A1736936B7A1}"/>
@@ -8546,9 +8619,10 @@
     <dgm:cxn modelId="{AB66C215-FB74-3540-935F-56AA4A1EC490}" type="presOf" srcId="{B254D69F-715E-0243-A524-5971AF84E0A5}" destId="{74E1EE4E-5633-F746-8414-2E58AD18F8F7}" srcOrd="0" destOrd="4" presId="urn:microsoft.com/office/officeart/2005/8/layout/hList1"/>
     <dgm:cxn modelId="{92E70118-CDBB-8A45-8E52-3770CD336D79}" srcId="{701A8435-98D4-3549-BD60-C83F7E74F191}" destId="{B8468E6A-8E1B-0745-A1C8-7F2809653837}" srcOrd="2" destOrd="0" parTransId="{0106EE98-ACD1-7840-9D37-7DE7882764E5}" sibTransId="{F61E2965-7F05-BE4E-8954-1C50E0D7C182}"/>
     <dgm:cxn modelId="{51B9AE18-6C6F-9542-8018-36D1434B992D}" type="presOf" srcId="{FDDEB88A-4DC7-9D45-AFF5-3C8FD998C362}" destId="{2393E5E2-B7D6-5649-940D-13F8B1FB5DDE}" srcOrd="0" destOrd="11" presId="urn:microsoft.com/office/officeart/2005/8/layout/hList1"/>
+    <dgm:cxn modelId="{6302DF1B-1E63-954C-BE02-31CB1CAC04DB}" srcId="{B8468E6A-8E1B-0745-A1C8-7F2809653837}" destId="{B0368CA6-3685-7049-9DC6-C905636ABE29}" srcOrd="2" destOrd="0" parTransId="{832D3D1D-F3EC-354B-83D2-C9577F7CD6F5}" sibTransId="{5C7AEDA3-B26D-9A4A-9C25-646FDD6B5C48}"/>
     <dgm:cxn modelId="{4D672A1C-F612-AB40-9DCA-A0AD2DF9DDAA}" srcId="{F2A05C70-64D0-174F-96CA-8D8886A42700}" destId="{8D20E67D-3A07-AA41-B404-A87C88C5C70E}" srcOrd="5" destOrd="0" parTransId="{2317B1D7-F169-4047-BA6E-F410EB45BC6C}" sibTransId="{F27E3436-CAF6-B24F-B27C-A7533DE3943B}"/>
     <dgm:cxn modelId="{0506FC1D-688F-F446-B875-30A149D54B15}" srcId="{B8468E6A-8E1B-0745-A1C8-7F2809653837}" destId="{80F623A2-663E-7C43-A716-4C569470CBF7}" srcOrd="1" destOrd="0" parTransId="{1C7E42E7-A0FA-1248-AE8F-41015BD85AB2}" sibTransId="{1AA32129-003F-3646-BA15-AB7FCA45FC7C}"/>
-    <dgm:cxn modelId="{E241BE1E-F9B2-A440-84BA-E3D12D5A4A9A}" srcId="{206B004E-E561-9D43-B840-3F6B468C6D72}" destId="{BF8B952B-2003-5B44-BCE6-DFF9A4A923C3}" srcOrd="5" destOrd="0" parTransId="{9378E088-AB13-D94B-8736-4E37B9E81383}" sibTransId="{80781C40-E15B-4C49-A822-6A52EFCB2A6D}"/>
+    <dgm:cxn modelId="{E241BE1E-F9B2-A440-84BA-E3D12D5A4A9A}" srcId="{206B004E-E561-9D43-B840-3F6B468C6D72}" destId="{BF8B952B-2003-5B44-BCE6-DFF9A4A923C3}" srcOrd="6" destOrd="0" parTransId="{9378E088-AB13-D94B-8736-4E37B9E81383}" sibTransId="{80781C40-E15B-4C49-A822-6A52EFCB2A6D}"/>
     <dgm:cxn modelId="{7DC25520-1B2C-D34E-9A89-8DF2D1EF0982}" type="presOf" srcId="{6B5EDEFC-6BE4-9E41-B48A-080F6CAEF84A}" destId="{74E1EE4E-5633-F746-8414-2E58AD18F8F7}" srcOrd="0" destOrd="10" presId="urn:microsoft.com/office/officeart/2005/8/layout/hList1"/>
     <dgm:cxn modelId="{61C5A220-0144-1748-B60B-5DB7B42483D3}" type="presOf" srcId="{C4D63277-072D-2449-A305-78FF1D0E393F}" destId="{CE5F70C5-46D1-F941-BA20-6505D8125C99}" srcOrd="0" destOrd="6" presId="urn:microsoft.com/office/officeart/2005/8/layout/hList1"/>
     <dgm:cxn modelId="{2428CD22-2B1A-4B4E-9EB4-73335817DB25}" srcId="{206B004E-E561-9D43-B840-3F6B468C6D72}" destId="{C7D5B991-1BC7-8C4E-82D8-FFDF94B0E59C}" srcOrd="3" destOrd="0" parTransId="{5198F1AE-41BA-5942-8C5F-75C7606377FE}" sibTransId="{965991F2-71BE-0843-A0F4-E8720193B808}"/>
@@ -8576,18 +8650,18 @@
     <dgm:cxn modelId="{CC508E45-B4C7-5E41-B95E-D2A09F2F25DE}" type="presOf" srcId="{99AD2E7D-79DA-E24A-B78F-9417E9660602}" destId="{2CA682A4-E48E-8D4E-90D8-411450594F85}" srcOrd="0" destOrd="0" presId="urn:microsoft.com/office/officeart/2005/8/layout/hList1"/>
     <dgm:cxn modelId="{11F94946-96ED-454D-AC18-E6BD28FA8268}" srcId="{0E81084C-665F-7A40-8621-288823A6D91A}" destId="{E09B1F53-129E-8249-AEEF-FB033B3A5D94}" srcOrd="4" destOrd="0" parTransId="{28245792-1298-5E47-8A2A-79903EB044CF}" sibTransId="{71F77F02-C259-C740-8BE7-3AAE5AA5CE93}"/>
     <dgm:cxn modelId="{FF5FCE48-46CF-BF43-9C72-CDF12CDCF718}" srcId="{3C31C087-F44D-3242-BEF1-1419442F0CB5}" destId="{99AD2E7D-79DA-E24A-B78F-9417E9660602}" srcOrd="0" destOrd="0" parTransId="{67CA6591-828C-F64D-AABD-09C9E7D0C913}" sibTransId="{2279764C-30C1-814F-BF28-C2A9A414B7CB}"/>
-    <dgm:cxn modelId="{22A0E54B-149B-7B42-A36E-FA79CA9C2801}" type="presOf" srcId="{F5EE2E8D-178D-904E-9DA7-1D4E95E8904A}" destId="{7113D888-A091-0148-B809-558500F11730}" srcOrd="0" destOrd="8" presId="urn:microsoft.com/office/officeart/2005/8/layout/hList1"/>
+    <dgm:cxn modelId="{22A0E54B-149B-7B42-A36E-FA79CA9C2801}" type="presOf" srcId="{F5EE2E8D-178D-904E-9DA7-1D4E95E8904A}" destId="{7113D888-A091-0148-B809-558500F11730}" srcOrd="0" destOrd="9" presId="urn:microsoft.com/office/officeart/2005/8/layout/hList1"/>
     <dgm:cxn modelId="{1D7D1D4F-E9DF-2A46-B465-7A91AE5511A5}" srcId="{701A8435-98D4-3549-BD60-C83F7E74F191}" destId="{AB2CDD92-925D-204B-A59B-AD5220182575}" srcOrd="0" destOrd="0" parTransId="{BB6D2DB1-3495-6641-AFC0-C75BABE8BE91}" sibTransId="{475C5DCB-9A7A-D644-A08F-1E3BE812A6D8}"/>
     <dgm:cxn modelId="{25C5CD51-7AE8-6740-8056-FDC273A28EC7}" srcId="{820B0744-2C7F-1B4D-B396-CAF01C0D130F}" destId="{7436DB42-B52C-884E-A6D7-8ADB46043202}" srcOrd="3" destOrd="0" parTransId="{0F167388-B0AB-914D-BB9A-289A79674926}" sibTransId="{2D41F13B-5CA8-3E4D-BEC0-330042C5E32F}"/>
     <dgm:cxn modelId="{65B61353-CA83-E84B-A4E2-A9C7364D69A6}" type="presOf" srcId="{686936BA-D5C0-EC4A-868F-D26B7C113448}" destId="{2CA682A4-E48E-8D4E-90D8-411450594F85}" srcOrd="0" destOrd="1" presId="urn:microsoft.com/office/officeart/2005/8/layout/hList1"/>
     <dgm:cxn modelId="{EE0CFA54-EECE-E542-893F-09BE91DFBCBC}" srcId="{820B0744-2C7F-1B4D-B396-CAF01C0D130F}" destId="{E102F523-103D-094C-BAD1-80A66945A501}" srcOrd="5" destOrd="0" parTransId="{47036F25-1C97-654C-9AE1-721E0C2A4CC3}" sibTransId="{E99830F8-ACD0-EA45-A8EB-6182D2ED639C}"/>
-    <dgm:cxn modelId="{964CA357-3A7C-994E-8A87-8A85B9997EFD}" srcId="{206B004E-E561-9D43-B840-3F6B468C6D72}" destId="{49D1358D-4D41-384E-B2F7-E6F4F09F7E67}" srcOrd="6" destOrd="0" parTransId="{761D4E9C-B66B-AF4C-8422-F3250E437019}" sibTransId="{BBC70B9C-C2D0-B64E-8299-B872EFB24171}"/>
-    <dgm:cxn modelId="{4F259358-D52E-A54E-83D1-702AB5B526DF}" type="presOf" srcId="{1B26BEAE-5FEC-944C-BE31-B52B509E0E53}" destId="{7113D888-A091-0148-B809-558500F11730}" srcOrd="0" destOrd="7" presId="urn:microsoft.com/office/officeart/2005/8/layout/hList1"/>
+    <dgm:cxn modelId="{964CA357-3A7C-994E-8A87-8A85B9997EFD}" srcId="{206B004E-E561-9D43-B840-3F6B468C6D72}" destId="{49D1358D-4D41-384E-B2F7-E6F4F09F7E67}" srcOrd="7" destOrd="0" parTransId="{761D4E9C-B66B-AF4C-8422-F3250E437019}" sibTransId="{BBC70B9C-C2D0-B64E-8299-B872EFB24171}"/>
+    <dgm:cxn modelId="{4F259358-D52E-A54E-83D1-702AB5B526DF}" type="presOf" srcId="{1B26BEAE-5FEC-944C-BE31-B52B509E0E53}" destId="{7113D888-A091-0148-B809-558500F11730}" srcOrd="0" destOrd="8" presId="urn:microsoft.com/office/officeart/2005/8/layout/hList1"/>
     <dgm:cxn modelId="{DCC8185E-FAD7-E84C-9604-80F82E9FA1BC}" srcId="{206B004E-E561-9D43-B840-3F6B468C6D72}" destId="{0E742E11-124E-384E-AFFB-A23152CEE719}" srcOrd="1" destOrd="0" parTransId="{5A4B3559-9328-BB4F-8D0E-F9B6DEA6F56F}" sibTransId="{462CFEB2-5E9E-4C4F-9878-14273AED566D}"/>
     <dgm:cxn modelId="{16532E61-3A3E-6940-AB18-3A5F6A711BCC}" type="presOf" srcId="{AB21FAB3-D1DD-054E-BE72-C786F59958BA}" destId="{2CA682A4-E48E-8D4E-90D8-411450594F85}" srcOrd="0" destOrd="6" presId="urn:microsoft.com/office/officeart/2005/8/layout/hList1"/>
     <dgm:cxn modelId="{79403F68-0ED2-3A4B-96C7-A7B1EF47F483}" srcId="{0E81084C-665F-7A40-8621-288823A6D91A}" destId="{F4D66D96-F046-5B44-B0C7-051EC1EE70AE}" srcOrd="0" destOrd="0" parTransId="{41D1D2CD-A962-6344-8EAB-396463A7D4D6}" sibTransId="{ECD85B36-06EE-EF47-BBF9-E11DDAE13C9D}"/>
     <dgm:cxn modelId="{5E8B5569-428C-2249-82A1-F4DEB5B4A782}" type="presOf" srcId="{7DEEE778-FB69-3D44-9697-B17E09D7B2DB}" destId="{74E1EE4E-5633-F746-8414-2E58AD18F8F7}" srcOrd="0" destOrd="9" presId="urn:microsoft.com/office/officeart/2005/8/layout/hList1"/>
-    <dgm:cxn modelId="{191B6369-225A-B04E-B93B-C4791DFDD384}" srcId="{206B004E-E561-9D43-B840-3F6B468C6D72}" destId="{896F5E05-25CF-D043-86FA-E1CEA8AB293A}" srcOrd="7" destOrd="0" parTransId="{19FF46E6-C9F0-ED43-AEB3-D4E975347DF2}" sibTransId="{784590CB-23C5-3F42-8CD0-A73E95874341}"/>
+    <dgm:cxn modelId="{191B6369-225A-B04E-B93B-C4791DFDD384}" srcId="{206B004E-E561-9D43-B840-3F6B468C6D72}" destId="{896F5E05-25CF-D043-86FA-E1CEA8AB293A}" srcOrd="8" destOrd="0" parTransId="{19FF46E6-C9F0-ED43-AEB3-D4E975347DF2}" sibTransId="{784590CB-23C5-3F42-8CD0-A73E95874341}"/>
     <dgm:cxn modelId="{C7DA6C6B-C13F-274A-BC5F-D0D041D98FA1}" type="presOf" srcId="{3CE228BE-3DA7-D54A-807B-2E5ED5F6DD6A}" destId="{74E1EE4E-5633-F746-8414-2E58AD18F8F7}" srcOrd="0" destOrd="8" presId="urn:microsoft.com/office/officeart/2005/8/layout/hList1"/>
     <dgm:cxn modelId="{9B45D46B-27DE-774F-8471-14269DC8BA60}" srcId="{3C31C087-F44D-3242-BEF1-1419442F0CB5}" destId="{4AA251AB-84E7-044C-8617-65DE459D5F9C}" srcOrd="3" destOrd="0" parTransId="{085837C2-7808-5D4D-B04D-9E36EBA1ADD5}" sibTransId="{3935C031-F101-924C-8379-CB82F07E656B}"/>
     <dgm:cxn modelId="{B412166C-8C03-8D46-B276-DDADA2D22884}" srcId="{0E81084C-665F-7A40-8621-288823A6D91A}" destId="{4B82FEA6-0005-4E48-9B77-482E895B516F}" srcOrd="5" destOrd="0" parTransId="{B4DD944A-D5B9-AF42-B845-B36C0DE4D9E3}" sibTransId="{EDF6518B-2FE9-114F-A472-E2EF2B3127F2}"/>
@@ -8602,7 +8676,7 @@
     <dgm:cxn modelId="{852B2476-7391-B741-83D6-BC7CD63CC5CF}" srcId="{528B0447-750C-B84B-B38E-6C4CE45E8FD1}" destId="{A321B8A5-163C-434B-8166-8417C171943F}" srcOrd="4" destOrd="0" parTransId="{704BCBA0-4C0A-E64C-8B2C-852846922F3B}" sibTransId="{9AA37B3A-4FAC-0847-A539-57EC9460ECA4}"/>
     <dgm:cxn modelId="{77042E78-6DDA-BC49-8661-9387EAB234BC}" type="presOf" srcId="{6B49D39A-09DD-EB47-8425-DD7594735C12}" destId="{2393E5E2-B7D6-5649-940D-13F8B1FB5DDE}" srcOrd="0" destOrd="10" presId="urn:microsoft.com/office/officeart/2005/8/layout/hList1"/>
     <dgm:cxn modelId="{7C57A779-9B75-A441-8E4B-7FCEA3F0AD8A}" srcId="{701A8435-98D4-3549-BD60-C83F7E74F191}" destId="{6C06993D-B491-964D-B99D-8C27CDDA630B}" srcOrd="4" destOrd="0" parTransId="{5E36E03B-10B5-AA4A-AF14-2BF4C803554B}" sibTransId="{67B889D3-AEEF-F940-9B04-FF8883885EAC}"/>
-    <dgm:cxn modelId="{289DE67A-3CCD-0D43-B03D-09D6B77EF9E9}" type="presOf" srcId="{EDC322EC-8913-FA44-BFEA-EB8A17064908}" destId="{7113D888-A091-0148-B809-558500F11730}" srcOrd="0" destOrd="5" presId="urn:microsoft.com/office/officeart/2005/8/layout/hList1"/>
+    <dgm:cxn modelId="{289DE67A-3CCD-0D43-B03D-09D6B77EF9E9}" type="presOf" srcId="{EDC322EC-8913-FA44-BFEA-EB8A17064908}" destId="{7113D888-A091-0148-B809-558500F11730}" srcOrd="0" destOrd="6" presId="urn:microsoft.com/office/officeart/2005/8/layout/hList1"/>
     <dgm:cxn modelId="{85D3117B-A24E-C94F-BD68-BD0D9784CB46}" srcId="{3C31C087-F44D-3242-BEF1-1419442F0CB5}" destId="{E523040D-A447-1042-BA36-72E85C383DF2}" srcOrd="5" destOrd="0" parTransId="{8BA02416-4B0F-4F43-86EB-0859FBE1DE0F}" sibTransId="{C8C7ABCE-1723-A741-85EF-985EBE6500C3}"/>
     <dgm:cxn modelId="{AD054A7C-B143-FC4D-AA8F-DF3B9EF0F6F0}" srcId="{528B0447-750C-B84B-B38E-6C4CE45E8FD1}" destId="{F5F257FC-0F24-6141-9068-4345FD753125}" srcOrd="5" destOrd="0" parTransId="{7B6FE9C2-012A-314F-B61B-3470B9694868}" sibTransId="{910ECA95-67BA-FA46-8327-0EE5199EB945}"/>
     <dgm:cxn modelId="{C4E1AF7E-6883-DD4E-B1C1-427A600C8A11}" type="presOf" srcId="{4A398511-53DF-CF47-A780-1C44D366175E}" destId="{7113D888-A091-0148-B809-558500F11730}" srcOrd="0" destOrd="1" presId="urn:microsoft.com/office/officeart/2005/8/layout/hList1"/>
@@ -8625,29 +8699,30 @@
     <dgm:cxn modelId="{92242DA1-0FCF-EE45-9B58-18822382684D}" srcId="{F2A05C70-64D0-174F-96CA-8D8886A42700}" destId="{B77C66BA-0BC9-E645-9AE4-A94A934B6380}" srcOrd="2" destOrd="0" parTransId="{C4980A73-A4AF-FF4E-B240-8F0C5C1CCCA9}" sibTransId="{B5A06249-26FE-2240-8CB7-FC69215D0643}"/>
     <dgm:cxn modelId="{4206A1A3-1EC8-1B40-A4FB-CF376096D110}" srcId="{F2A05C70-64D0-174F-96CA-8D8886A42700}" destId="{F7B2B710-5229-6442-A5BB-FE5304B1A538}" srcOrd="7" destOrd="0" parTransId="{72615336-FF5B-9B47-A0B7-91F5C4F3E2B7}" sibTransId="{21BE7B36-0059-7C47-B7CD-4DBFCA159CE9}"/>
     <dgm:cxn modelId="{6FE47CA4-9939-DB4C-BF8F-80FA874E14AF}" type="presOf" srcId="{6800FABE-AB0E-2243-8CCB-75294127D6A9}" destId="{44166239-56FF-E042-BB85-390DFA25077A}" srcOrd="0" destOrd="3" presId="urn:microsoft.com/office/officeart/2005/8/layout/hList1"/>
-    <dgm:cxn modelId="{3D64E7A7-080A-2E41-9296-67E40A6E7388}" type="presOf" srcId="{8B85AFBA-DE6C-5A42-AD2A-6896D82A8B33}" destId="{1A71BF6A-449B-F446-83EE-5DE84234424B}" srcOrd="0" destOrd="9" presId="urn:microsoft.com/office/officeart/2005/8/layout/hList1"/>
+    <dgm:cxn modelId="{3D64E7A7-080A-2E41-9296-67E40A6E7388}" type="presOf" srcId="{8B85AFBA-DE6C-5A42-AD2A-6896D82A8B33}" destId="{1A71BF6A-449B-F446-83EE-5DE84234424B}" srcOrd="0" destOrd="10" presId="urn:microsoft.com/office/officeart/2005/8/layout/hList1"/>
     <dgm:cxn modelId="{2808E7A8-6DC3-5440-BBF4-7857551E537B}" srcId="{820B0744-2C7F-1B4D-B396-CAF01C0D130F}" destId="{2128AB4E-2A43-B342-AB0C-88935E772827}" srcOrd="6" destOrd="0" parTransId="{C3A772BA-76E5-6342-9ADD-330974B7EF3F}" sibTransId="{B5E5F56A-8B91-3D4E-A196-9E6D67A89E0C}"/>
     <dgm:cxn modelId="{F29689AB-7B13-CD4B-99A8-C47FF39B0124}" srcId="{820B0744-2C7F-1B4D-B396-CAF01C0D130F}" destId="{7DEEE778-FB69-3D44-9697-B17E09D7B2DB}" srcOrd="9" destOrd="0" parTransId="{6F75C5DE-68E0-1149-9171-19614592D551}" sibTransId="{40D5D2E3-91EA-7B48-91C1-C8B9192874F2}"/>
     <dgm:cxn modelId="{F4A5E0AB-3195-AC46-A77B-4F32ECC49660}" srcId="{528B0447-750C-B84B-B38E-6C4CE45E8FD1}" destId="{C214054E-5CC8-DA45-B001-BA21D367E041}" srcOrd="3" destOrd="0" parTransId="{4D14E27F-D5D7-5449-8156-4504F3B30B08}" sibTransId="{63BB4124-BB57-694E-92CE-9B30F3AEBBA4}"/>
     <dgm:cxn modelId="{DC5819AC-EF20-A849-9C84-820961DE6121}" srcId="{62282A74-D35E-914B-81CD-953B68F50298}" destId="{F2A05C70-64D0-174F-96CA-8D8886A42700}" srcOrd="5" destOrd="0" parTransId="{44A8759A-C202-B44B-AC56-AEFA053499C8}" sibTransId="{CC3E2A9E-8753-8043-BC04-CF631D59C516}"/>
-    <dgm:cxn modelId="{972720AF-385A-7A48-9F60-C5216D0DB9BD}" type="presOf" srcId="{49D1358D-4D41-384E-B2F7-E6F4F09F7E67}" destId="{1A71BF6A-449B-F446-83EE-5DE84234424B}" srcOrd="0" destOrd="6" presId="urn:microsoft.com/office/officeart/2005/8/layout/hList1"/>
+    <dgm:cxn modelId="{972720AF-385A-7A48-9F60-C5216D0DB9BD}" type="presOf" srcId="{49D1358D-4D41-384E-B2F7-E6F4F09F7E67}" destId="{1A71BF6A-449B-F446-83EE-5DE84234424B}" srcOrd="0" destOrd="7" presId="urn:microsoft.com/office/officeart/2005/8/layout/hList1"/>
     <dgm:cxn modelId="{AAA7BFAF-E83C-2844-B0D9-16EB70997929}" srcId="{F2A05C70-64D0-174F-96CA-8D8886A42700}" destId="{85D1BFC8-C584-854E-A8D0-0FA66BD1D850}" srcOrd="6" destOrd="0" parTransId="{D6D0422D-528E-4946-B4FC-E0C42A882B54}" sibTransId="{C4C5E3C5-47DA-524C-8777-30C1B93CB5A8}"/>
     <dgm:cxn modelId="{FFC6FCAF-782C-FA42-8B8E-2E467020F627}" srcId="{62282A74-D35E-914B-81CD-953B68F50298}" destId="{3C31C087-F44D-3242-BEF1-1419442F0CB5}" srcOrd="3" destOrd="0" parTransId="{105A726B-6D0B-9F4F-81A8-E2C4EEBBD6F1}" sibTransId="{CE3177CF-2976-BC4A-971A-7018F81F441F}"/>
     <dgm:cxn modelId="{1D1739B0-96B5-CD45-8EAC-9D50A219FAFA}" srcId="{206B004E-E561-9D43-B840-3F6B468C6D72}" destId="{970AE76A-4E71-1F48-84AE-D00A44441EC0}" srcOrd="0" destOrd="0" parTransId="{C01298A0-54CB-FB4A-BD0C-FC58677051D1}" sibTransId="{036F49E1-49FC-8745-8A66-E5011A6BD455}"/>
     <dgm:cxn modelId="{A243C4B0-0D89-B14C-9D15-45FE3081C53E}" type="presOf" srcId="{7436DB42-B52C-884E-A6D7-8ADB46043202}" destId="{74E1EE4E-5633-F746-8414-2E58AD18F8F7}" srcOrd="0" destOrd="3" presId="urn:microsoft.com/office/officeart/2005/8/layout/hList1"/>
     <dgm:cxn modelId="{84D552B6-DF39-6344-8773-6B859CBD301D}" srcId="{49D1358D-4D41-384E-B2F7-E6F4F09F7E67}" destId="{8B85AFBA-DE6C-5A42-AD2A-6896D82A8B33}" srcOrd="2" destOrd="0" parTransId="{55AD51B5-32B4-5445-BC36-D2BEAB3B3ED6}" sibTransId="{EEE2BF60-0FB9-A244-8979-98BCAB6C64B6}"/>
     <dgm:cxn modelId="{BA9A3CBB-AA46-604F-A6A2-E2628ECCA894}" srcId="{0E81084C-665F-7A40-8621-288823A6D91A}" destId="{6800FABE-AB0E-2243-8CCB-75294127D6A9}" srcOrd="3" destOrd="0" parTransId="{F32FCCFE-31DD-F84B-86A6-770DAB35C8FB}" sibTransId="{977EB8A6-A7B6-C74F-A45E-D6C790DCF009}"/>
-    <dgm:cxn modelId="{765422BD-A54D-FB4C-BD69-BCDF3F337BD4}" type="presOf" srcId="{6CC0AC49-BE78-084C-ABCA-42C7F12B8A8F}" destId="{1A71BF6A-449B-F446-83EE-5DE84234424B}" srcOrd="0" destOrd="8" presId="urn:microsoft.com/office/officeart/2005/8/layout/hList1"/>
+    <dgm:cxn modelId="{765422BD-A54D-FB4C-BD69-BCDF3F337BD4}" type="presOf" srcId="{6CC0AC49-BE78-084C-ABCA-42C7F12B8A8F}" destId="{1A71BF6A-449B-F446-83EE-5DE84234424B}" srcOrd="0" destOrd="9" presId="urn:microsoft.com/office/officeart/2005/8/layout/hList1"/>
     <dgm:cxn modelId="{721410BE-8436-104E-AF35-EEE8F44703B6}" type="presOf" srcId="{206B004E-E561-9D43-B840-3F6B468C6D72}" destId="{A65C912B-5A8B-F74D-91B5-61A3D50B2E45}" srcOrd="0" destOrd="0" presId="urn:microsoft.com/office/officeart/2005/8/layout/hList1"/>
     <dgm:cxn modelId="{4E23A0BF-BA16-8F43-B025-85724307BB25}" srcId="{206B004E-E561-9D43-B840-3F6B468C6D72}" destId="{D2766A73-1CE5-8C44-8ED4-6E12D9EF6899}" srcOrd="4" destOrd="0" parTransId="{48D14EFE-D12B-CA4C-AADF-4AB490D7429A}" sibTransId="{08EEAB3C-54D8-7C40-BD53-E595E7E37ABC}"/>
     <dgm:cxn modelId="{774207C0-DCEB-7C4B-BBCC-17DB9F175511}" srcId="{820B0744-2C7F-1B4D-B396-CAF01C0D130F}" destId="{B254D69F-715E-0243-A524-5971AF84E0A5}" srcOrd="4" destOrd="0" parTransId="{BF206AE7-9C8F-824D-983C-E6BED96A1939}" sibTransId="{BD7EB29D-6E3A-FE46-A5DC-7F37B509AEE9}"/>
     <dgm:cxn modelId="{8BA346C0-0A2D-0A4B-BA62-1E667B387D00}" type="presOf" srcId="{6391025A-3A69-1943-94CC-8B519575DDA6}" destId="{2CA682A4-E48E-8D4E-90D8-411450594F85}" srcOrd="0" destOrd="7" presId="urn:microsoft.com/office/officeart/2005/8/layout/hList1"/>
     <dgm:cxn modelId="{244B6CC0-7B3C-2748-80D2-9876E0505EA6}" type="presOf" srcId="{E102F523-103D-094C-BAD1-80A66945A501}" destId="{74E1EE4E-5633-F746-8414-2E58AD18F8F7}" srcOrd="0" destOrd="5" presId="urn:microsoft.com/office/officeart/2005/8/layout/hList1"/>
+    <dgm:cxn modelId="{95D195C0-F1D1-4742-8F3C-71A40ACD34BA}" srcId="{206B004E-E561-9D43-B840-3F6B468C6D72}" destId="{42B02ACF-D616-EC44-9BE1-D85A6BD01522}" srcOrd="5" destOrd="0" parTransId="{61A02348-1472-D146-A7DD-46D29810294F}" sibTransId="{CFFDA296-0EAD-AA48-96D9-F25D49F9ECE9}"/>
     <dgm:cxn modelId="{3AF1D6C0-1937-134E-9BD2-651B8302486F}" type="presOf" srcId="{4B6AC34A-8917-5E40-9F26-228F6CAF027E}" destId="{2393E5E2-B7D6-5649-940D-13F8B1FB5DDE}" srcOrd="0" destOrd="6" presId="urn:microsoft.com/office/officeart/2005/8/layout/hList1"/>
     <dgm:cxn modelId="{8F47EAC0-1CEC-8B48-BE17-5FFDDB41D86F}" type="presOf" srcId="{A321B8A5-163C-434B-8166-8417C171943F}" destId="{CE5F70C5-46D1-F941-BA20-6505D8125C99}" srcOrd="0" destOrd="4" presId="urn:microsoft.com/office/officeart/2005/8/layout/hList1"/>
-    <dgm:cxn modelId="{2046F2C2-FA11-9446-A1F5-0EB5CCF896DA}" type="presOf" srcId="{F5BD1AD7-5263-F34A-8F5E-D48054B18CA7}" destId="{1A71BF6A-449B-F446-83EE-5DE84234424B}" srcOrd="0" destOrd="7" presId="urn:microsoft.com/office/officeart/2005/8/layout/hList1"/>
+    <dgm:cxn modelId="{2046F2C2-FA11-9446-A1F5-0EB5CCF896DA}" type="presOf" srcId="{F5BD1AD7-5263-F34A-8F5E-D48054B18CA7}" destId="{1A71BF6A-449B-F446-83EE-5DE84234424B}" srcOrd="0" destOrd="8" presId="urn:microsoft.com/office/officeart/2005/8/layout/hList1"/>
     <dgm:cxn modelId="{2F2F95C4-1436-9D4A-A1D6-A17F1654907B}" srcId="{F2A05C70-64D0-174F-96CA-8D8886A42700}" destId="{9C74DA0A-4734-174E-8832-B8B63E6ABFD9}" srcOrd="10" destOrd="0" parTransId="{0CBCCD76-3B0C-DC40-85B5-A6DB1100E27D}" sibTransId="{9174EAE3-7709-894B-94F0-62AD29E2315A}"/>
-    <dgm:cxn modelId="{349878C5-3622-7047-B95C-F4E761CCD4E2}" type="presOf" srcId="{6C06993D-B491-964D-B99D-8C27CDDA630B}" destId="{7113D888-A091-0148-B809-558500F11730}" srcOrd="0" destOrd="6" presId="urn:microsoft.com/office/officeart/2005/8/layout/hList1"/>
+    <dgm:cxn modelId="{349878C5-3622-7047-B95C-F4E761CCD4E2}" type="presOf" srcId="{6C06993D-B491-964D-B99D-8C27CDDA630B}" destId="{7113D888-A091-0148-B809-558500F11730}" srcOrd="0" destOrd="7" presId="urn:microsoft.com/office/officeart/2005/8/layout/hList1"/>
     <dgm:cxn modelId="{1439E7C5-B41E-AB4C-B9FA-EDF1E6CD2A13}" type="presOf" srcId="{F4D66D96-F046-5B44-B0C7-051EC1EE70AE}" destId="{44166239-56FF-E042-BB85-390DFA25077A}" srcOrd="0" destOrd="0" presId="urn:microsoft.com/office/officeart/2005/8/layout/hList1"/>
     <dgm:cxn modelId="{D93F47C8-A8D2-B04E-8713-556062CDAB27}" type="presOf" srcId="{62282A74-D35E-914B-81CD-953B68F50298}" destId="{2297FE90-F822-FD41-9896-D1D149AA928E}" srcOrd="0" destOrd="0" presId="urn:microsoft.com/office/officeart/2005/8/layout/hList1"/>
     <dgm:cxn modelId="{4876B7C9-0DBD-0E40-A4A4-689A1BE01B6F}" type="presOf" srcId="{528B0447-750C-B84B-B38E-6C4CE45E8FD1}" destId="{B1F44652-1785-2342-919B-E792338E35F3}" srcOrd="0" destOrd="0" presId="urn:microsoft.com/office/officeart/2005/8/layout/hList1"/>
@@ -8655,6 +8730,7 @@
     <dgm:cxn modelId="{A5D9B3CB-E1DC-0D4A-A531-2474DE8E3001}" srcId="{F2A05C70-64D0-174F-96CA-8D8886A42700}" destId="{D38751D8-04D3-FB41-BE50-113186CE9249}" srcOrd="1" destOrd="0" parTransId="{A78064D7-7A89-EA43-ACDF-E39D7A3F4F61}" sibTransId="{09CA87E1-4539-FD49-9A77-507ACC50A220}"/>
     <dgm:cxn modelId="{5237ECCF-89EB-054F-91E8-45B094B3B269}" srcId="{3C31C087-F44D-3242-BEF1-1419442F0CB5}" destId="{CC00DBD9-F17A-354F-9030-64A4E788101D}" srcOrd="2" destOrd="0" parTransId="{906511A2-35E4-524A-BEC5-740C4EA818BE}" sibTransId="{C55EB23B-3D0E-AA4A-BE3C-712FD4561C16}"/>
     <dgm:cxn modelId="{006C6FD5-E5DE-EA48-9C9D-686B338A1B01}" srcId="{B8468E6A-8E1B-0745-A1C8-7F2809653837}" destId="{EFFEC21E-48DF-7943-AF91-AA2559DECB59}" srcOrd="0" destOrd="0" parTransId="{F523FD2A-E716-DD42-84F2-843AF8AFEC6D}" sibTransId="{B6AE7174-648A-164D-A23F-13A9BAF6E459}"/>
+    <dgm:cxn modelId="{06D691D7-D115-094B-A0B6-51D1C74C006F}" type="presOf" srcId="{B0368CA6-3685-7049-9DC6-C905636ABE29}" destId="{7113D888-A091-0148-B809-558500F11730}" srcOrd="0" destOrd="5" presId="urn:microsoft.com/office/officeart/2005/8/layout/hList1"/>
     <dgm:cxn modelId="{ED7E93D7-049E-9F49-BDA9-BA7FEDE7770E}" type="presOf" srcId="{C214054E-5CC8-DA45-B001-BA21D367E041}" destId="{CE5F70C5-46D1-F941-BA20-6505D8125C99}" srcOrd="0" destOrd="3" presId="urn:microsoft.com/office/officeart/2005/8/layout/hList1"/>
     <dgm:cxn modelId="{5AE113D8-F3AD-8244-9E6F-248ED637F20F}" srcId="{F2A05C70-64D0-174F-96CA-8D8886A42700}" destId="{6B49D39A-09DD-EB47-8425-DD7594735C12}" srcOrd="8" destOrd="0" parTransId="{37AE19E0-34F7-914F-AD42-03F2D76A5924}" sibTransId="{B168F7A7-BFE2-8944-8EF6-93508F9C3F47}"/>
     <dgm:cxn modelId="{028491D9-D372-0747-95B4-C680930183D6}" srcId="{820B0744-2C7F-1B4D-B396-CAF01C0D130F}" destId="{60696620-E2C0-B64C-9D22-E13B74596ECB}" srcOrd="1" destOrd="0" parTransId="{94E9C171-0BDF-B040-A4C9-740212CF4B38}" sibTransId="{B36373FA-502D-ED4C-B821-30F88124FF67}"/>
@@ -8666,7 +8742,7 @@
     <dgm:cxn modelId="{9700F6DC-3618-274C-ADD6-A954EFDF64D8}" srcId="{820B0744-2C7F-1B4D-B396-CAF01C0D130F}" destId="{3CE228BE-3DA7-D54A-807B-2E5ED5F6DD6A}" srcOrd="8" destOrd="0" parTransId="{4E170F47-5A3A-8F4B-B58C-19E8743C14F0}" sibTransId="{9942E02B-94B7-3B46-B80F-C87306B01D69}"/>
     <dgm:cxn modelId="{92B389E3-BC05-BA4D-9A12-4738CED5717F}" srcId="{62282A74-D35E-914B-81CD-953B68F50298}" destId="{206B004E-E561-9D43-B840-3F6B468C6D72}" srcOrd="6" destOrd="0" parTransId="{8B80118A-01E9-7E43-833F-62CCCF5732F8}" sibTransId="{281B787A-D136-2A4B-B3F4-17FA3E5F46EE}"/>
     <dgm:cxn modelId="{9AAA5BE5-2F39-E947-A94E-7C7979F9F356}" type="presOf" srcId="{2128AB4E-2A43-B342-AB0C-88935E772827}" destId="{74E1EE4E-5633-F746-8414-2E58AD18F8F7}" srcOrd="0" destOrd="6" presId="urn:microsoft.com/office/officeart/2005/8/layout/hList1"/>
-    <dgm:cxn modelId="{BFD991E6-82C9-0342-BE81-006EADB169CE}" type="presOf" srcId="{BF8B952B-2003-5B44-BCE6-DFF9A4A923C3}" destId="{1A71BF6A-449B-F446-83EE-5DE84234424B}" srcOrd="0" destOrd="5" presId="urn:microsoft.com/office/officeart/2005/8/layout/hList1"/>
+    <dgm:cxn modelId="{BFD991E6-82C9-0342-BE81-006EADB169CE}" type="presOf" srcId="{BF8B952B-2003-5B44-BCE6-DFF9A4A923C3}" destId="{1A71BF6A-449B-F446-83EE-5DE84234424B}" srcOrd="0" destOrd="6" presId="urn:microsoft.com/office/officeart/2005/8/layout/hList1"/>
     <dgm:cxn modelId="{BB7F3BE7-E72C-AC46-B059-97C9BAC8F69A}" type="presOf" srcId="{0E742E11-124E-384E-AFFB-A23152CEE719}" destId="{1A71BF6A-449B-F446-83EE-5DE84234424B}" srcOrd="0" destOrd="1" presId="urn:microsoft.com/office/officeart/2005/8/layout/hList1"/>
     <dgm:cxn modelId="{0EF4E3E8-D34B-C842-8C87-7B3B8A90CEBB}" srcId="{F2A05C70-64D0-174F-96CA-8D8886A42700}" destId="{4B6AC34A-8917-5E40-9F26-228F6CAF027E}" srcOrd="4" destOrd="0" parTransId="{39C22C08-49F9-1E4E-83FC-A0AC6D41823E}" sibTransId="{756BB98C-0CCF-5543-B22E-3E7FBB797843}"/>
     <dgm:cxn modelId="{7AAD65EB-101E-3D4F-874C-D4770BB86562}" srcId="{528B0447-750C-B84B-B38E-6C4CE45E8FD1}" destId="{04617FC7-A425-B64B-8696-4ADB18F1CD25}" srcOrd="1" destOrd="0" parTransId="{9E672A7D-4D71-6749-B1AF-0BD19A501EB0}" sibTransId="{84A4B815-6010-9B4B-806B-AE0B4B73FEEB}"/>
@@ -8680,6 +8756,7 @@
     <dgm:cxn modelId="{58EFA6F8-4B5C-1145-B0F7-3A0B799D0054}" type="presOf" srcId="{134844F8-E973-3E46-BD4B-F27661DC996E}" destId="{CE5F70C5-46D1-F941-BA20-6505D8125C99}" srcOrd="0" destOrd="0" presId="urn:microsoft.com/office/officeart/2005/8/layout/hList1"/>
     <dgm:cxn modelId="{6EB4F8F8-F868-5E42-B600-71B885758D38}" type="presOf" srcId="{820B0744-2C7F-1B4D-B396-CAF01C0D130F}" destId="{6555432B-9DF8-724F-8E30-71C0601F40F0}" srcOrd="0" destOrd="0" presId="urn:microsoft.com/office/officeart/2005/8/layout/hList1"/>
     <dgm:cxn modelId="{80CAEBF9-4EE4-EE44-8D39-60F30E0E83A1}" srcId="{3C31C087-F44D-3242-BEF1-1419442F0CB5}" destId="{686936BA-D5C0-EC4A-868F-D26B7C113448}" srcOrd="1" destOrd="0" parTransId="{9A96633A-56F2-C242-990E-268896D5E1CD}" sibTransId="{CCFABE67-DAF6-EB41-808E-2811D6964336}"/>
+    <dgm:cxn modelId="{8F33C9FA-3A63-1840-83F2-FF3E2427A310}" type="presOf" srcId="{42B02ACF-D616-EC44-9BE1-D85A6BD01522}" destId="{1A71BF6A-449B-F446-83EE-5DE84234424B}" srcOrd="0" destOrd="5" presId="urn:microsoft.com/office/officeart/2005/8/layout/hList1"/>
     <dgm:cxn modelId="{D1076170-F336-C944-8AB1-7F3F77FD24AE}" type="presParOf" srcId="{2297FE90-F822-FD41-9896-D1D149AA928E}" destId="{7B98A648-2BBA-174B-A6E1-55852336FD2B}" srcOrd="0" destOrd="0" presId="urn:microsoft.com/office/officeart/2005/8/layout/hList1"/>
     <dgm:cxn modelId="{56D42CF7-C22E-1E42-9D49-842B5CE50AE4}" type="presParOf" srcId="{7B98A648-2BBA-174B-A6E1-55852336FD2B}" destId="{FBF6FE0A-A1E0-D940-999E-D6642ED4A453}" srcOrd="0" destOrd="0" presId="urn:microsoft.com/office/officeart/2005/8/layout/hList1"/>
     <dgm:cxn modelId="{8CF871D1-2C42-B04C-8B7E-E027EFDEABB9}" type="presParOf" srcId="{7B98A648-2BBA-174B-A6E1-55852336FD2B}" destId="{44166239-56FF-E042-BB85-390DFA25077A}" srcOrd="1" destOrd="0" presId="urn:microsoft.com/office/officeart/2005/8/layout/hList1"/>
@@ -9587,6 +9664,24 @@
             </a:rPr>
             <a:t>• variance stabilization</a:t>
           </a:r>
+        </a:p>
+        <a:p>
+          <a:pPr marL="0" lvl="0" indent="0" algn="l" defTabSz="577850">
+            <a:lnSpc>
+              <a:spcPct val="90000"/>
+            </a:lnSpc>
+            <a:spcBef>
+              <a:spcPct val="0"/>
+            </a:spcBef>
+            <a:spcAft>
+              <a:spcPct val="35000"/>
+            </a:spcAft>
+            <a:buNone/>
+          </a:pPr>
+          <a:endParaRPr lang="en-US" sz="1300" kern="1200" dirty="0">
+            <a:latin typeface="Helvetica" pitchFamily="2" charset="0"/>
+            <a:cs typeface="Arial" panose="020B0604020202020204" pitchFamily="34" charset="0"/>
+          </a:endParaRPr>
         </a:p>
         <a:p>
           <a:pPr marL="0" lvl="0" indent="0" algn="l" defTabSz="577850">
@@ -10536,7 +10631,7 @@
           </a:endParaRPr>
         </a:p>
         <a:p>
-          <a:pPr marL="0" lvl="0" indent="0" algn="l" defTabSz="622300">
+          <a:pPr marL="0" lvl="0" indent="0" algn="ctr" defTabSz="622300">
             <a:lnSpc>
               <a:spcPct val="90000"/>
             </a:lnSpc>
@@ -10557,7 +10652,7 @@
           </a:r>
         </a:p>
         <a:p>
-          <a:pPr marL="0" lvl="0" indent="0" algn="l" defTabSz="622300">
+          <a:pPr marL="0" lvl="0" indent="0" algn="ctr" defTabSz="622300">
             <a:lnSpc>
               <a:spcPct val="90000"/>
             </a:lnSpc>
@@ -10587,7 +10682,7 @@
           </a:r>
         </a:p>
         <a:p>
-          <a:pPr marL="0" lvl="0" indent="0" algn="l" defTabSz="622300">
+          <a:pPr marL="0" lvl="0" indent="0" algn="ctr" defTabSz="622300">
             <a:lnSpc>
               <a:spcPct val="90000"/>
             </a:lnSpc>
@@ -10605,7 +10700,7 @@
           </a:endParaRPr>
         </a:p>
         <a:p>
-          <a:pPr marL="0" lvl="0" indent="0" algn="l" defTabSz="622300">
+          <a:pPr marL="0" lvl="0" indent="0" algn="ctr" defTabSz="622300">
             <a:lnSpc>
               <a:spcPct val="90000"/>
             </a:lnSpc>
@@ -10623,7 +10718,7 @@
           </a:endParaRPr>
         </a:p>
         <a:p>
-          <a:pPr marL="0" lvl="0" indent="0" algn="l" defTabSz="622300">
+          <a:pPr marL="0" lvl="0" indent="0" algn="ctr" defTabSz="622300">
             <a:lnSpc>
               <a:spcPct val="90000"/>
             </a:lnSpc>
@@ -11002,7 +11097,7 @@
       </dsp:nvSpPr>
       <dsp:spPr>
         <a:xfrm>
-          <a:off x="5294" y="1269998"/>
+          <a:off x="5294" y="1200629"/>
           <a:ext cx="1398571" cy="428732"/>
         </a:xfrm>
         <a:prstGeom prst="rect">
@@ -11125,7 +11220,7 @@
         </a:p>
       </dsp:txBody>
       <dsp:txXfrm>
-        <a:off x="5294" y="1269998"/>
+        <a:off x="5294" y="1200629"/>
         <a:ext cx="1398571" cy="428732"/>
       </dsp:txXfrm>
     </dsp:sp>
@@ -11136,8 +11231,8 @@
       </dsp:nvSpPr>
       <dsp:spPr>
         <a:xfrm>
-          <a:off x="539" y="1700781"/>
-          <a:ext cx="1398571" cy="2384143"/>
+          <a:off x="539" y="1631531"/>
+          <a:ext cx="1398571" cy="2522883"/>
         </a:xfrm>
         <a:prstGeom prst="rect">
           <a:avLst/>
@@ -11330,8 +11425,8 @@
         </a:p>
       </dsp:txBody>
       <dsp:txXfrm>
-        <a:off x="539" y="1700781"/>
-        <a:ext cx="1398571" cy="2384143"/>
+        <a:off x="539" y="1631531"/>
+        <a:ext cx="1398571" cy="2522883"/>
       </dsp:txXfrm>
     </dsp:sp>
     <dsp:sp modelId="{4A0BD58D-1EEF-3545-8F73-6B4F3C6D0024}">
@@ -11341,7 +11436,7 @@
       </dsp:nvSpPr>
       <dsp:spPr>
         <a:xfrm>
-          <a:off x="1609819" y="1269998"/>
+          <a:off x="1609819" y="1200629"/>
           <a:ext cx="1398571" cy="428732"/>
         </a:xfrm>
         <a:prstGeom prst="rect">
@@ -11464,7 +11559,7 @@
         </a:p>
       </dsp:txBody>
       <dsp:txXfrm>
-        <a:off x="1609819" y="1269998"/>
+        <a:off x="1609819" y="1200629"/>
         <a:ext cx="1398571" cy="428732"/>
       </dsp:txXfrm>
     </dsp:sp>
@@ -11475,8 +11570,8 @@
       </dsp:nvSpPr>
       <dsp:spPr>
         <a:xfrm>
-          <a:off x="1609819" y="1698731"/>
-          <a:ext cx="1398571" cy="2384143"/>
+          <a:off x="1609819" y="1629361"/>
+          <a:ext cx="1398571" cy="2522883"/>
         </a:xfrm>
         <a:prstGeom prst="rect">
           <a:avLst/>
@@ -11650,6 +11745,24 @@
           </a:r>
         </a:p>
         <a:p>
+          <a:pPr marL="114300" lvl="2" indent="-57150" algn="l" defTabSz="400050">
+            <a:lnSpc>
+              <a:spcPct val="90000"/>
+            </a:lnSpc>
+            <a:spcBef>
+              <a:spcPct val="0"/>
+            </a:spcBef>
+            <a:spcAft>
+              <a:spcPct val="15000"/>
+            </a:spcAft>
+            <a:buFont typeface="Courier New" panose="02070309020205020404" pitchFamily="49" charset="0"/>
+            <a:buChar char="o"/>
+          </a:pPr>
+          <a:endParaRPr lang="en-US" sz="900" b="0" i="0" u="none" kern="1200" dirty="0">
+            <a:latin typeface="Helvetica" pitchFamily="2" charset="0"/>
+          </a:endParaRPr>
+        </a:p>
+        <a:p>
           <a:pPr marL="57150" lvl="1" indent="-57150" algn="l" defTabSz="400050">
             <a:lnSpc>
               <a:spcPct val="90000"/>
@@ -11746,8 +11859,8 @@
         </a:p>
       </dsp:txBody>
       <dsp:txXfrm>
-        <a:off x="1609819" y="1698731"/>
-        <a:ext cx="1398571" cy="2384143"/>
+        <a:off x="1609819" y="1629361"/>
+        <a:ext cx="1398571" cy="2522883"/>
       </dsp:txXfrm>
     </dsp:sp>
     <dsp:sp modelId="{6555432B-9DF8-724F-8E30-71C0601F40F0}">
@@ -11757,7 +11870,7 @@
       </dsp:nvSpPr>
       <dsp:spPr>
         <a:xfrm>
-          <a:off x="3204190" y="1269998"/>
+          <a:off x="3204190" y="1200629"/>
           <a:ext cx="1398571" cy="428732"/>
         </a:xfrm>
         <a:prstGeom prst="rect">
@@ -11880,7 +11993,7 @@
         </a:p>
       </dsp:txBody>
       <dsp:txXfrm>
-        <a:off x="3204190" y="1269998"/>
+        <a:off x="3204190" y="1200629"/>
         <a:ext cx="1398571" cy="428732"/>
       </dsp:txXfrm>
     </dsp:sp>
@@ -11891,8 +12004,8 @@
       </dsp:nvSpPr>
       <dsp:spPr>
         <a:xfrm>
-          <a:off x="3204190" y="1698731"/>
-          <a:ext cx="1398571" cy="2384143"/>
+          <a:off x="3204190" y="1629361"/>
+          <a:ext cx="1398571" cy="2522883"/>
         </a:xfrm>
         <a:prstGeom prst="rect">
           <a:avLst/>
@@ -12180,8 +12293,8 @@
         </a:p>
       </dsp:txBody>
       <dsp:txXfrm>
-        <a:off x="3204190" y="1698731"/>
-        <a:ext cx="1398571" cy="2384143"/>
+        <a:off x="3204190" y="1629361"/>
+        <a:ext cx="1398571" cy="2522883"/>
       </dsp:txXfrm>
     </dsp:sp>
     <dsp:sp modelId="{763EEBA5-2A97-7545-B388-BB57D917C4C6}">
@@ -12191,7 +12304,7 @@
       </dsp:nvSpPr>
       <dsp:spPr>
         <a:xfrm>
-          <a:off x="4798561" y="1269998"/>
+          <a:off x="4798561" y="1200629"/>
           <a:ext cx="1398571" cy="428732"/>
         </a:xfrm>
         <a:prstGeom prst="rect">
@@ -12297,7 +12410,7 @@
         </a:p>
       </dsp:txBody>
       <dsp:txXfrm>
-        <a:off x="4798561" y="1269998"/>
+        <a:off x="4798561" y="1200629"/>
         <a:ext cx="1398571" cy="428732"/>
       </dsp:txXfrm>
     </dsp:sp>
@@ -12308,8 +12421,8 @@
       </dsp:nvSpPr>
       <dsp:spPr>
         <a:xfrm>
-          <a:off x="4798561" y="1698731"/>
-          <a:ext cx="1398571" cy="2384143"/>
+          <a:off x="4798561" y="1629361"/>
+          <a:ext cx="1398571" cy="2522883"/>
         </a:xfrm>
         <a:prstGeom prst="rect">
           <a:avLst/>
@@ -12523,8 +12636,8 @@
         </a:p>
       </dsp:txBody>
       <dsp:txXfrm>
-        <a:off x="4798561" y="1698731"/>
-        <a:ext cx="1398571" cy="2384143"/>
+        <a:off x="4798561" y="1629361"/>
+        <a:ext cx="1398571" cy="2522883"/>
       </dsp:txXfrm>
     </dsp:sp>
     <dsp:sp modelId="{B1F44652-1785-2342-919B-E792338E35F3}">
@@ -12534,7 +12647,7 @@
       </dsp:nvSpPr>
       <dsp:spPr>
         <a:xfrm>
-          <a:off x="6392932" y="1269998"/>
+          <a:off x="6392932" y="1200629"/>
           <a:ext cx="1398571" cy="428732"/>
         </a:xfrm>
         <a:prstGeom prst="rect">
@@ -12643,7 +12756,7 @@
         </a:p>
       </dsp:txBody>
       <dsp:txXfrm>
-        <a:off x="6392932" y="1269998"/>
+        <a:off x="6392932" y="1200629"/>
         <a:ext cx="1398571" cy="428732"/>
       </dsp:txXfrm>
     </dsp:sp>
@@ -12654,8 +12767,8 @@
       </dsp:nvSpPr>
       <dsp:spPr>
         <a:xfrm>
-          <a:off x="6392932" y="1698731"/>
-          <a:ext cx="1398571" cy="2384143"/>
+          <a:off x="6392932" y="1629361"/>
+          <a:ext cx="1398571" cy="2522883"/>
         </a:xfrm>
         <a:prstGeom prst="rect">
           <a:avLst/>
@@ -12847,8 +12960,8 @@
         </a:p>
       </dsp:txBody>
       <dsp:txXfrm>
-        <a:off x="6392932" y="1698731"/>
-        <a:ext cx="1398571" cy="2384143"/>
+        <a:off x="6392932" y="1629361"/>
+        <a:ext cx="1398571" cy="2522883"/>
       </dsp:txXfrm>
     </dsp:sp>
     <dsp:sp modelId="{BB209C84-3A08-FB4C-A922-B95B7FDD58EF}">
@@ -12858,7 +12971,7 @@
       </dsp:nvSpPr>
       <dsp:spPr>
         <a:xfrm>
-          <a:off x="7987219" y="1281574"/>
+          <a:off x="7987219" y="1212204"/>
           <a:ext cx="1398571" cy="428732"/>
         </a:xfrm>
         <a:prstGeom prst="rect">
@@ -12964,7 +13077,7 @@
         </a:p>
       </dsp:txBody>
       <dsp:txXfrm>
-        <a:off x="7987219" y="1281574"/>
+        <a:off x="7987219" y="1212204"/>
         <a:ext cx="1398571" cy="428732"/>
       </dsp:txXfrm>
     </dsp:sp>
@@ -12975,8 +13088,8 @@
       </dsp:nvSpPr>
       <dsp:spPr>
         <a:xfrm>
-          <a:off x="7987303" y="1698731"/>
-          <a:ext cx="1398571" cy="2384143"/>
+          <a:off x="7987303" y="1629361"/>
+          <a:ext cx="1398571" cy="2522883"/>
         </a:xfrm>
         <a:prstGeom prst="rect">
           <a:avLst/>
@@ -13342,8 +13455,8 @@
         </a:p>
       </dsp:txBody>
       <dsp:txXfrm>
-        <a:off x="7987303" y="1698731"/>
-        <a:ext cx="1398571" cy="2384143"/>
+        <a:off x="7987303" y="1629361"/>
+        <a:ext cx="1398571" cy="2522883"/>
       </dsp:txXfrm>
     </dsp:sp>
     <dsp:sp modelId="{A65C912B-5A8B-F74D-91B5-61A3D50B2E45}">
@@ -13353,7 +13466,7 @@
       </dsp:nvSpPr>
       <dsp:spPr>
         <a:xfrm>
-          <a:off x="9581674" y="1269998"/>
+          <a:off x="9581674" y="1200629"/>
           <a:ext cx="1398571" cy="428732"/>
         </a:xfrm>
         <a:prstGeom prst="rect">
@@ -13462,7 +13575,7 @@
         </a:p>
       </dsp:txBody>
       <dsp:txXfrm>
-        <a:off x="9581674" y="1269998"/>
+        <a:off x="9581674" y="1200629"/>
         <a:ext cx="1398571" cy="428732"/>
       </dsp:txXfrm>
     </dsp:sp>
@@ -13473,8 +13586,8 @@
       </dsp:nvSpPr>
       <dsp:spPr>
         <a:xfrm>
-          <a:off x="9581674" y="1698731"/>
-          <a:ext cx="1398571" cy="2384143"/>
+          <a:off x="9581674" y="1629361"/>
+          <a:ext cx="1398571" cy="2522883"/>
         </a:xfrm>
         <a:prstGeom prst="rect">
           <a:avLst/>
@@ -13634,6 +13747,24 @@
             <a:spcAft>
               <a:spcPct val="15000"/>
             </a:spcAft>
+            <a:buFont typeface="Arial" panose="020B0604020202020204" pitchFamily="34" charset="0"/>
+            <a:buChar char="•"/>
+          </a:pPr>
+          <a:endParaRPr lang="en-US" sz="900" b="0" i="0" u="none" kern="1200" dirty="0">
+            <a:latin typeface="Helvetica" pitchFamily="2" charset="0"/>
+          </a:endParaRPr>
+        </a:p>
+        <a:p>
+          <a:pPr marL="57150" lvl="1" indent="-57150" algn="l" defTabSz="400050">
+            <a:lnSpc>
+              <a:spcPct val="90000"/>
+            </a:lnSpc>
+            <a:spcBef>
+              <a:spcPct val="0"/>
+            </a:spcBef>
+            <a:spcAft>
+              <a:spcPct val="15000"/>
+            </a:spcAft>
             <a:buNone/>
           </a:pPr>
           <a:r>
@@ -13747,8 +13878,8 @@
         </a:p>
       </dsp:txBody>
       <dsp:txXfrm>
-        <a:off x="9581674" y="1698731"/>
-        <a:ext cx="1398571" cy="2384143"/>
+        <a:off x="9581674" y="1629361"/>
+        <a:ext cx="1398571" cy="2522883"/>
       </dsp:txXfrm>
     </dsp:sp>
   </dsp:spTree>
@@ -17960,7 +18091,7 @@
           <a:p>
             <a:fld id="{EC4B1B13-748A-F541-9268-9AEDB03B338F}" type="datetimeFigureOut">
               <a:rPr lang="en-US" smtClean="0"/>
-              <a:t>12/16/25</a:t>
+              <a:t>12/18/25</a:t>
             </a:fld>
             <a:endParaRPr lang="en-US"/>
           </a:p>
@@ -18724,7 +18855,7 @@
           <a:p>
             <a:fld id="{51E66395-EB46-4B40-BBC8-664D9551475E}" type="datetimeFigureOut">
               <a:rPr lang="en-US" smtClean="0"/>
-              <a:t>12/16/25</a:t>
+              <a:t>12/18/25</a:t>
             </a:fld>
             <a:endParaRPr lang="en-US"/>
           </a:p>
@@ -18922,7 +19053,7 @@
           <a:p>
             <a:fld id="{51E66395-EB46-4B40-BBC8-664D9551475E}" type="datetimeFigureOut">
               <a:rPr lang="en-US" smtClean="0"/>
-              <a:t>12/16/25</a:t>
+              <a:t>12/18/25</a:t>
             </a:fld>
             <a:endParaRPr lang="en-US"/>
           </a:p>
@@ -19130,7 +19261,7 @@
           <a:p>
             <a:fld id="{51E66395-EB46-4B40-BBC8-664D9551475E}" type="datetimeFigureOut">
               <a:rPr lang="en-US" smtClean="0"/>
-              <a:t>12/16/25</a:t>
+              <a:t>12/18/25</a:t>
             </a:fld>
             <a:endParaRPr lang="en-US"/>
           </a:p>
@@ -19328,7 +19459,7 @@
           <a:p>
             <a:fld id="{51E66395-EB46-4B40-BBC8-664D9551475E}" type="datetimeFigureOut">
               <a:rPr lang="en-US" smtClean="0"/>
-              <a:t>12/16/25</a:t>
+              <a:t>12/18/25</a:t>
             </a:fld>
             <a:endParaRPr lang="en-US"/>
           </a:p>
@@ -19603,7 +19734,7 @@
           <a:p>
             <a:fld id="{51E66395-EB46-4B40-BBC8-664D9551475E}" type="datetimeFigureOut">
               <a:rPr lang="en-US" smtClean="0"/>
-              <a:t>12/16/25</a:t>
+              <a:t>12/18/25</a:t>
             </a:fld>
             <a:endParaRPr lang="en-US"/>
           </a:p>
@@ -19868,7 +19999,7 @@
           <a:p>
             <a:fld id="{51E66395-EB46-4B40-BBC8-664D9551475E}" type="datetimeFigureOut">
               <a:rPr lang="en-US" smtClean="0"/>
-              <a:t>12/16/25</a:t>
+              <a:t>12/18/25</a:t>
             </a:fld>
             <a:endParaRPr lang="en-US"/>
           </a:p>
@@ -20280,7 +20411,7 @@
           <a:p>
             <a:fld id="{51E66395-EB46-4B40-BBC8-664D9551475E}" type="datetimeFigureOut">
               <a:rPr lang="en-US" smtClean="0"/>
-              <a:t>12/16/25</a:t>
+              <a:t>12/18/25</a:t>
             </a:fld>
             <a:endParaRPr lang="en-US"/>
           </a:p>
@@ -20421,7 +20552,7 @@
           <a:p>
             <a:fld id="{51E66395-EB46-4B40-BBC8-664D9551475E}" type="datetimeFigureOut">
               <a:rPr lang="en-US" smtClean="0"/>
-              <a:t>12/16/25</a:t>
+              <a:t>12/18/25</a:t>
             </a:fld>
             <a:endParaRPr lang="en-US"/>
           </a:p>
@@ -20534,7 +20665,7 @@
           <a:p>
             <a:fld id="{51E66395-EB46-4B40-BBC8-664D9551475E}" type="datetimeFigureOut">
               <a:rPr lang="en-US" smtClean="0"/>
-              <a:t>12/16/25</a:t>
+              <a:t>12/18/25</a:t>
             </a:fld>
             <a:endParaRPr lang="en-US"/>
           </a:p>
@@ -20845,7 +20976,7 @@
           <a:p>
             <a:fld id="{51E66395-EB46-4B40-BBC8-664D9551475E}" type="datetimeFigureOut">
               <a:rPr lang="en-US" smtClean="0"/>
-              <a:t>12/16/25</a:t>
+              <a:t>12/18/25</a:t>
             </a:fld>
             <a:endParaRPr lang="en-US"/>
           </a:p>
@@ -21133,7 +21264,7 @@
           <a:p>
             <a:fld id="{51E66395-EB46-4B40-BBC8-664D9551475E}" type="datetimeFigureOut">
               <a:rPr lang="en-US" smtClean="0"/>
-              <a:t>12/16/25</a:t>
+              <a:t>12/18/25</a:t>
             </a:fld>
             <a:endParaRPr lang="en-US"/>
           </a:p>
@@ -21374,7 +21505,7 @@
           <a:p>
             <a:fld id="{51E66395-EB46-4B40-BBC8-664D9551475E}" type="datetimeFigureOut">
               <a:rPr lang="en-US" smtClean="0"/>
-              <a:t>12/16/25</a:t>
+              <a:t>12/18/25</a:t>
             </a:fld>
             <a:endParaRPr lang="en-US"/>
           </a:p>
@@ -22560,7 +22691,7 @@
           <p:nvPr>
             <p:extLst>
               <p:ext uri="{D42A27DB-BD31-4B8C-83A1-F6EECF244321}">
-                <p14:modId xmlns:p14="http://schemas.microsoft.com/office/powerpoint/2010/main" val="2355912038"/>
+                <p14:modId xmlns:p14="http://schemas.microsoft.com/office/powerpoint/2010/main" val="3172191992"/>
               </p:ext>
             </p:extLst>
           </p:nvPr>
@@ -22589,7 +22720,7 @@
         </p:nvSpPr>
         <p:spPr>
           <a:xfrm>
-            <a:off x="5818433" y="2057805"/>
+            <a:off x="5818433" y="2121603"/>
             <a:ext cx="45720" cy="182880"/>
           </a:xfrm>
           <a:prstGeom prst="downArrow">
@@ -22635,7 +22766,7 @@
         </p:nvSpPr>
         <p:spPr>
           <a:xfrm>
-            <a:off x="5841293" y="3205766"/>
+            <a:off x="5841293" y="3365261"/>
             <a:ext cx="45720" cy="182880"/>
           </a:xfrm>
           <a:prstGeom prst="downArrow">
@@ -22753,7 +22884,7 @@
           <p:nvPr>
             <p:extLst>
               <p:ext uri="{D42A27DB-BD31-4B8C-83A1-F6EECF244321}">
-                <p14:modId xmlns:p14="http://schemas.microsoft.com/office/powerpoint/2010/main" val="2646365232"/>
+                <p14:modId xmlns:p14="http://schemas.microsoft.com/office/powerpoint/2010/main" val="3436680111"/>
               </p:ext>
             </p:extLst>
           </p:nvPr>
@@ -23839,7 +23970,7 @@
         <p:spPr>
           <a:xfrm>
             <a:off x="811508" y="149657"/>
-            <a:ext cx="3791231" cy="307777"/>
+            <a:ext cx="7722499" cy="584775"/>
           </a:xfrm>
           <a:prstGeom prst="rect">
             <a:avLst/>
@@ -23859,8 +23990,15 @@
                 </a:solidFill>
                 <a:latin typeface="Helvetica" pitchFamily="2" charset="0"/>
               </a:rPr>
-              <a:t>B. Dimensionality reduction: PCA &amp; UMAP</a:t>
+              <a:t>B. </a:t>
             </a:r>
+            <a:r>
+              <a:rPr lang="en-US" b="1" dirty="0"/>
+              <a:t>Low-dimensional representations for trajectory and structure analysis</a:t>
+            </a:r>
+            <a:endParaRPr lang="en-US" dirty="0"/>
+          </a:p>
+          <a:p>
             <a:endParaRPr lang="en-US" sz="1400" dirty="0">
               <a:latin typeface="Helvetica" pitchFamily="2" charset="0"/>
             </a:endParaRPr>
@@ -24163,7 +24301,7 @@
           <p:nvPr>
             <p:extLst>
               <p:ext uri="{D42A27DB-BD31-4B8C-83A1-F6EECF244321}">
-                <p14:modId xmlns:p14="http://schemas.microsoft.com/office/powerpoint/2010/main" val="1026344038"/>
+                <p14:modId xmlns:p14="http://schemas.microsoft.com/office/powerpoint/2010/main" val="782229048"/>
               </p:ext>
             </p:extLst>
           </p:nvPr>

</xml_diff>

<commit_message>
Lock Figures 1 and 3; add initial Figure 4 RHOG synthesis
</commit_message>
<xml_diff>
--- a/figures/fig1_pipeline/Fig1_panels.pptx
+++ b/figures/fig1_pipeline/Fig1_panels.pptx
@@ -2578,7 +2578,7 @@
               <a:latin typeface="Helvetica" pitchFamily="2" charset="0"/>
               <a:cs typeface="Arial" panose="020B0604020202020204" pitchFamily="34" charset="0"/>
             </a:rPr>
-            <a:t>Data acquisition &amp; preprocessing</a:t>
+            <a:t>A. Data acquisition &amp; preprocessing</a:t>
           </a:r>
           <a:endParaRPr lang="en-US" sz="1800" b="0" dirty="0">
             <a:latin typeface="Helvetica" pitchFamily="2" charset="0"/>
@@ -8413,10 +8413,24 @@
     <dgm:pt modelId="{61A02348-1472-D146-A7DD-46D29810294F}" type="parTrans" cxnId="{95D195C0-F1D1-4742-8F3C-71A40ACD34BA}">
       <dgm:prSet/>
       <dgm:spPr/>
+      <dgm:t>
+        <a:bodyPr/>
+        <a:lstStyle/>
+        <a:p>
+          <a:endParaRPr lang="en-US"/>
+        </a:p>
+      </dgm:t>
     </dgm:pt>
     <dgm:pt modelId="{CFFDA296-0EAD-AA48-96D9-F25D49F9ECE9}" type="sibTrans" cxnId="{95D195C0-F1D1-4742-8F3C-71A40ACD34BA}">
       <dgm:prSet/>
       <dgm:spPr/>
+      <dgm:t>
+        <a:bodyPr/>
+        <a:lstStyle/>
+        <a:p>
+          <a:endParaRPr lang="en-US"/>
+        </a:p>
+      </dgm:t>
     </dgm:pt>
     <dgm:pt modelId="{2297FE90-F822-FD41-9896-D1D149AA928E}" type="pres">
       <dgm:prSet presAssocID="{62282A74-D35E-914B-81CD-953B68F50298}" presName="Name0" presStyleCnt="0">
@@ -8878,7 +8892,7 @@
               <a:latin typeface="Helvetica" pitchFamily="2" charset="0"/>
               <a:cs typeface="Arial" panose="020B0604020202020204" pitchFamily="34" charset="0"/>
             </a:rPr>
-            <a:t>Data acquisition &amp; preprocessing</a:t>
+            <a:t>A. Data acquisition &amp; preprocessing</a:t>
           </a:r>
           <a:endParaRPr lang="en-US" sz="1800" b="0" kern="1200" dirty="0">
             <a:latin typeface="Helvetica" pitchFamily="2" charset="0"/>
@@ -22455,229 +22469,6 @@
           <a:chExt cx="0" cy="0"/>
         </a:xfrm>
       </p:grpSpPr>
-      <p:sp>
-        <p:nvSpPr>
-          <p:cNvPr id="2" name="Rectangle 1">
-            <a:extLst>
-              <a:ext uri="{FF2B5EF4-FFF2-40B4-BE49-F238E27FC236}">
-                <a16:creationId xmlns:a16="http://schemas.microsoft.com/office/drawing/2014/main" id="{58CB7E67-F3AC-471E-DC7A-23F51B367C59}"/>
-              </a:ext>
-            </a:extLst>
-          </p:cNvPr>
-          <p:cNvSpPr>
-            <a:spLocks noChangeArrowheads="1"/>
-          </p:cNvSpPr>
-          <p:nvPr/>
-        </p:nvSpPr>
-        <p:spPr bwMode="auto">
-          <a:xfrm>
-            <a:off x="1544320" y="1044776"/>
-            <a:ext cx="5549406" cy="369332"/>
-          </a:xfrm>
-          <a:prstGeom prst="rect">
-            <a:avLst/>
-          </a:prstGeom>
-          <a:noFill/>
-          <a:ln>
-            <a:noFill/>
-          </a:ln>
-          <a:effectLst/>
-          <a:extLst>
-            <a:ext uri="{909E8E84-426E-40DD-AFC4-6F175D3DCCD1}">
-              <a14:hiddenFill xmlns:a14="http://schemas.microsoft.com/office/drawing/2010/main">
-                <a:solidFill>
-                  <a:schemeClr val="accent1"/>
-                </a:solidFill>
-              </a14:hiddenFill>
-            </a:ext>
-            <a:ext uri="{91240B29-F687-4F45-9708-019B960494DF}">
-              <a14:hiddenLine xmlns:a14="http://schemas.microsoft.com/office/drawing/2010/main" w="9525">
-                <a:solidFill>
-                  <a:schemeClr val="tx1"/>
-                </a:solidFill>
-                <a:miter lim="800000"/>
-                <a:headEnd/>
-                <a:tailEnd/>
-              </a14:hiddenLine>
-            </a:ext>
-            <a:ext uri="{AF507438-7753-43E0-B8FC-AC1667EBCBE1}">
-              <a14:hiddenEffects xmlns:a14="http://schemas.microsoft.com/office/drawing/2010/main">
-                <a:effectLst>
-                  <a:outerShdw dist="35921" dir="2700000" algn="ctr" rotWithShape="0">
-                    <a:schemeClr val="bg2"/>
-                  </a:outerShdw>
-                </a:effectLst>
-              </a14:hiddenEffects>
-            </a:ext>
-          </a:extLst>
-        </p:spPr>
-        <p:txBody>
-          <a:bodyPr vert="horz" wrap="square" lIns="91440" tIns="45720" rIns="91440" bIns="45720" numCol="1" anchor="ctr" anchorCtr="0" compatLnSpc="1">
-            <a:prstTxWarp prst="textNoShape">
-              <a:avLst/>
-            </a:prstTxWarp>
-            <a:spAutoFit/>
-          </a:bodyPr>
-          <a:lstStyle>
-            <a:lvl1pPr eaLnBrk="0" fontAlgn="base" hangingPunct="0">
-              <a:spcBef>
-                <a:spcPct val="0"/>
-              </a:spcBef>
-              <a:spcAft>
-                <a:spcPct val="0"/>
-              </a:spcAft>
-              <a:defRPr>
-                <a:solidFill>
-                  <a:schemeClr val="tx1"/>
-                </a:solidFill>
-                <a:latin typeface="Arial" panose="020B0604020202020204" pitchFamily="34" charset="0"/>
-              </a:defRPr>
-            </a:lvl1pPr>
-            <a:lvl2pPr eaLnBrk="0" fontAlgn="base" hangingPunct="0">
-              <a:spcBef>
-                <a:spcPct val="0"/>
-              </a:spcBef>
-              <a:spcAft>
-                <a:spcPct val="0"/>
-              </a:spcAft>
-              <a:defRPr>
-                <a:solidFill>
-                  <a:schemeClr val="tx1"/>
-                </a:solidFill>
-                <a:latin typeface="Arial" panose="020B0604020202020204" pitchFamily="34" charset="0"/>
-              </a:defRPr>
-            </a:lvl2pPr>
-            <a:lvl3pPr eaLnBrk="0" fontAlgn="base" hangingPunct="0">
-              <a:spcBef>
-                <a:spcPct val="0"/>
-              </a:spcBef>
-              <a:spcAft>
-                <a:spcPct val="0"/>
-              </a:spcAft>
-              <a:defRPr>
-                <a:solidFill>
-                  <a:schemeClr val="tx1"/>
-                </a:solidFill>
-                <a:latin typeface="Arial" panose="020B0604020202020204" pitchFamily="34" charset="0"/>
-              </a:defRPr>
-            </a:lvl3pPr>
-            <a:lvl4pPr eaLnBrk="0" fontAlgn="base" hangingPunct="0">
-              <a:spcBef>
-                <a:spcPct val="0"/>
-              </a:spcBef>
-              <a:spcAft>
-                <a:spcPct val="0"/>
-              </a:spcAft>
-              <a:defRPr>
-                <a:solidFill>
-                  <a:schemeClr val="tx1"/>
-                </a:solidFill>
-                <a:latin typeface="Arial" panose="020B0604020202020204" pitchFamily="34" charset="0"/>
-              </a:defRPr>
-            </a:lvl4pPr>
-            <a:lvl5pPr eaLnBrk="0" fontAlgn="base" hangingPunct="0">
-              <a:spcBef>
-                <a:spcPct val="0"/>
-              </a:spcBef>
-              <a:spcAft>
-                <a:spcPct val="0"/>
-              </a:spcAft>
-              <a:defRPr>
-                <a:solidFill>
-                  <a:schemeClr val="tx1"/>
-                </a:solidFill>
-                <a:latin typeface="Arial" panose="020B0604020202020204" pitchFamily="34" charset="0"/>
-              </a:defRPr>
-            </a:lvl5pPr>
-            <a:lvl6pPr eaLnBrk="0" fontAlgn="base" hangingPunct="0">
-              <a:spcBef>
-                <a:spcPct val="0"/>
-              </a:spcBef>
-              <a:spcAft>
-                <a:spcPct val="0"/>
-              </a:spcAft>
-              <a:defRPr>
-                <a:solidFill>
-                  <a:schemeClr val="tx1"/>
-                </a:solidFill>
-                <a:latin typeface="Arial" panose="020B0604020202020204" pitchFamily="34" charset="0"/>
-              </a:defRPr>
-            </a:lvl6pPr>
-            <a:lvl7pPr eaLnBrk="0" fontAlgn="base" hangingPunct="0">
-              <a:spcBef>
-                <a:spcPct val="0"/>
-              </a:spcBef>
-              <a:spcAft>
-                <a:spcPct val="0"/>
-              </a:spcAft>
-              <a:defRPr>
-                <a:solidFill>
-                  <a:schemeClr val="tx1"/>
-                </a:solidFill>
-                <a:latin typeface="Arial" panose="020B0604020202020204" pitchFamily="34" charset="0"/>
-              </a:defRPr>
-            </a:lvl7pPr>
-            <a:lvl8pPr eaLnBrk="0" fontAlgn="base" hangingPunct="0">
-              <a:spcBef>
-                <a:spcPct val="0"/>
-              </a:spcBef>
-              <a:spcAft>
-                <a:spcPct val="0"/>
-              </a:spcAft>
-              <a:defRPr>
-                <a:solidFill>
-                  <a:schemeClr val="tx1"/>
-                </a:solidFill>
-                <a:latin typeface="Arial" panose="020B0604020202020204" pitchFamily="34" charset="0"/>
-              </a:defRPr>
-            </a:lvl8pPr>
-            <a:lvl9pPr eaLnBrk="0" fontAlgn="base" hangingPunct="0">
-              <a:spcBef>
-                <a:spcPct val="0"/>
-              </a:spcBef>
-              <a:spcAft>
-                <a:spcPct val="0"/>
-              </a:spcAft>
-              <a:defRPr>
-                <a:solidFill>
-                  <a:schemeClr val="tx1"/>
-                </a:solidFill>
-                <a:latin typeface="Arial" panose="020B0604020202020204" pitchFamily="34" charset="0"/>
-              </a:defRPr>
-            </a:lvl9pPr>
-          </a:lstStyle>
-          <a:p>
-            <a:pPr lvl="0"/>
-            <a:r>
-              <a:rPr lang="en-US" altLang="en-US" b="1" dirty="0">
-                <a:solidFill>
-                  <a:srgbClr val="000000"/>
-                </a:solidFill>
-              </a:rPr>
-              <a:t>Panel A</a:t>
-            </a:r>
-            <a:r>
-              <a:rPr lang="en-US" altLang="en-US" dirty="0">
-                <a:solidFill>
-                  <a:srgbClr val="000000"/>
-                </a:solidFill>
-                <a:latin typeface="-webkit-standard"/>
-              </a:rPr>
-              <a:t> – Data &amp; Preprocessing</a:t>
-            </a:r>
-            <a:endParaRPr kumimoji="0" lang="en-US" altLang="en-US" sz="1800" b="0" i="0" u="none" strike="noStrike" cap="none" normalizeH="0" baseline="0" dirty="0">
-              <a:ln>
-                <a:noFill/>
-              </a:ln>
-              <a:solidFill>
-                <a:schemeClr val="tx1"/>
-              </a:solidFill>
-              <a:effectLst/>
-              <a:latin typeface="Arial" panose="020B0604020202020204" pitchFamily="34" charset="0"/>
-            </a:endParaRPr>
-          </a:p>
-        </p:txBody>
-      </p:sp>
       <p:graphicFrame>
         <p:nvGraphicFramePr>
           <p:cNvPr id="5" name="Diagram 4">
@@ -22691,7 +22482,7 @@
           <p:nvPr>
             <p:extLst>
               <p:ext uri="{D42A27DB-BD31-4B8C-83A1-F6EECF244321}">
-                <p14:modId xmlns:p14="http://schemas.microsoft.com/office/powerpoint/2010/main" val="3172191992"/>
+                <p14:modId xmlns:p14="http://schemas.microsoft.com/office/powerpoint/2010/main" val="3568938864"/>
               </p:ext>
             </p:extLst>
           </p:nvPr>
@@ -22720,8 +22511,8 @@
         </p:nvSpPr>
         <p:spPr>
           <a:xfrm>
-            <a:off x="5818433" y="2121603"/>
-            <a:ext cx="45720" cy="182880"/>
+            <a:off x="5936886" y="2063194"/>
+            <a:ext cx="54852" cy="182880"/>
           </a:xfrm>
           <a:prstGeom prst="downArrow">
             <a:avLst/>
@@ -22766,8 +22557,8 @@
         </p:nvSpPr>
         <p:spPr>
           <a:xfrm>
-            <a:off x="5841293" y="3365261"/>
-            <a:ext cx="45720" cy="182880"/>
+            <a:off x="5959746" y="3306852"/>
+            <a:ext cx="54852" cy="182880"/>
           </a:xfrm>
           <a:prstGeom prst="downArrow">
             <a:avLst/>
@@ -22812,7 +22603,7 @@
         </p:nvSpPr>
         <p:spPr>
           <a:xfrm>
-            <a:off x="1651441" y="401079"/>
+            <a:off x="1651441" y="414137"/>
             <a:ext cx="6096000" cy="307777"/>
           </a:xfrm>
           <a:prstGeom prst="rect">

</xml_diff>